<commit_message>
Slides: add Python validation framework slides (17-18), polish side-channel + baseline RTL slides
</commit_message>
<xml_diff>
--- a/PDP_group24.pptx
+++ b/PDP_group24.pptx
@@ -29798,7 +29798,7 @@
                   <a:srgbClr val="00B0F0"/>
                 </a:solidFill>
               </a:rPr>
-              <a:t>How we proved the masking actually works, before touching silicon</a:t>
+              <a:t>How we proved the masking works, in simulation and on hardware</a:t>
             </a:r>
           </a:p>
           <a:p>
@@ -29912,7 +29912,7 @@
                   <a:srgbClr val="555555"/>
                 </a:solidFill>
               </a:rPr>
-              <a:t>Why simulation: no board at design time. The model isolates the data-dependent switching at the register, de-risking the RTL ahead of the CW305 hardware campaign (Rishi's track).</a:t>
+              <a:t>Why simulation first: it isolates the register's switching with no analog noise, giving fast feedback in the RTL loop, alongside Rishi's CW305 hardware validation.</a:t>
             </a:r>
           </a:p>
         </p:txBody>

</xml_diff>

<commit_message>
Slides: rebuild baseline AES performance slide (9) as native table, align cycle numbers to profiling + results (59,560 -> 6,260, 9.5x)
</commit_message>
<xml_diff>
--- a/PDP_group24.pptx
+++ b/PDP_group24.pptx
@@ -35108,36 +35108,238 @@
           </a:p>
         </p:txBody>
       </p:sp>
-      <p:pic>
-        <p:nvPicPr>
-          <p:cNvPr id="2" name="Picture 1">
-            <a:extLst>
-              <a:ext uri="{FF2B5EF4-FFF2-40B4-BE49-F238E27FC236}">
-                <a16:creationId xmlns:a16="http://schemas.microsoft.com/office/drawing/2014/main" id="{D69CA29C-75F4-1571-63BD-9B26A5909881}"/>
-              </a:ext>
-            </a:extLst>
-          </p:cNvPr>
-          <p:cNvPicPr>
-            <a:picLocks noChangeAspect="1"/>
-          </p:cNvPicPr>
+      <p:sp>
+        <p:nvSpPr>
+          <p:cNvPr id="17" name="TextBox 16"/>
+          <p:cNvSpPr txBox="1"/>
           <p:nvPr/>
-        </p:nvPicPr>
-        <p:blipFill>
-          <a:blip r:embed="rId2"/>
-          <a:stretch>
-            <a:fillRect/>
-          </a:stretch>
-        </p:blipFill>
+        </p:nvSpPr>
         <p:spPr>
           <a:xfrm>
-            <a:off x="3464110" y="2643188"/>
-            <a:ext cx="4962525" cy="1571625"/>
+            <a:off x="713232" y="1371600"/>
+            <a:ext cx="10789920" cy="1005840"/>
           </a:xfrm>
           <a:prstGeom prst="rect">
             <a:avLst/>
           </a:prstGeom>
+          <a:noFill/>
         </p:spPr>
-      </p:pic>
+        <p:txBody>
+          <a:bodyPr wrap="square">
+            <a:spAutoFit/>
+          </a:bodyPr>
+          <a:lstStyle/>
+          <a:p>
+            <a:r>
+              <a:rPr sz="1900" b="1">
+                <a:solidFill>
+                  <a:srgbClr val="00B0F0"/>
+                </a:solidFill>
+              </a:rPr>
+              <a:t>aes32esmi does SubBytes + ShiftRows + MixColumns + AddRoundKey in a single cycle, removing the mix_columns bottleneck that was 83.8% of software runtime.</a:t>
+            </a:r>
+          </a:p>
+        </p:txBody>
+      </p:sp>
+      <p:graphicFrame>
+        <p:nvGraphicFramePr>
+          <p:cNvPr id="18" name="Table 17"/>
+          <p:cNvGraphicFramePr>
+            <a:graphicFrameLocks noGrp="1"/>
+          </p:cNvGraphicFramePr>
+          <p:nvPr/>
+        </p:nvGraphicFramePr>
+        <p:xfrm>
+          <a:off x="1280160" y="2697480"/>
+          <a:ext cx="9601200" cy="1463040"/>
+        </p:xfrm>
+        <a:graphic>
+          <a:graphicData uri="http://schemas.openxmlformats.org/drawingml/2006/table">
+            <a:tbl>
+              <a:tblPr firstRow="1" bandRow="1">
+                <a:tableStyleId>{5C22544A-7EE6-4342-B048-85BDC9FD1C3A}</a:tableStyleId>
+              </a:tblPr>
+              <a:tblGrid>
+                <a:gridCol w="4937760"/>
+                <a:gridCol w="2194560"/>
+                <a:gridCol w="2468880"/>
+              </a:tblGrid>
+              <a:tr h="487680">
+                <a:tc>
+                  <a:txBody>
+                    <a:bodyPr/>
+                    <a:lstStyle/>
+                    <a:p>
+                      <a:r>
+                        <a:rPr sz="1700" b="1">
+                          <a:solidFill>
+                            <a:srgbClr val="FFFFFF"/>
+                          </a:solidFill>
+                        </a:rPr>
+                        <a:t>Version</a:t>
+                      </a:r>
+                    </a:p>
+                  </a:txBody>
+                  <a:tcPr anchor="ctr"/>
+                </a:tc>
+                <a:tc>
+                  <a:txBody>
+                    <a:bodyPr/>
+                    <a:lstStyle/>
+                    <a:p>
+                      <a:r>
+                        <a:rPr sz="1700" b="1">
+                          <a:solidFill>
+                            <a:srgbClr val="FFFFFF"/>
+                          </a:solidFill>
+                        </a:rPr>
+                        <a:t>Cycles</a:t>
+                      </a:r>
+                    </a:p>
+                  </a:txBody>
+                  <a:tcPr anchor="ctr"/>
+                </a:tc>
+                <a:tc>
+                  <a:txBody>
+                    <a:bodyPr/>
+                    <a:lstStyle/>
+                    <a:p>
+                      <a:r>
+                        <a:rPr sz="1700" b="1">
+                          <a:solidFill>
+                            <a:srgbClr val="FFFFFF"/>
+                          </a:solidFill>
+                        </a:rPr>
+                        <a:t>vs software baseline</a:t>
+                      </a:r>
+                    </a:p>
+                  </a:txBody>
+                  <a:tcPr anchor="ctr"/>
+                </a:tc>
+              </a:tr>
+              <a:tr h="487680">
+                <a:tc>
+                  <a:txBody>
+                    <a:bodyPr/>
+                    <a:lstStyle/>
+                    <a:p>
+                      <a:r>
+                        <a:rPr sz="1700" b="1"/>
+                        <a:t>Software AES (baseline)</a:t>
+                      </a:r>
+                    </a:p>
+                  </a:txBody>
+                  <a:tcPr anchor="ctr"/>
+                </a:tc>
+                <a:tc>
+                  <a:txBody>
+                    <a:bodyPr/>
+                    <a:lstStyle/>
+                    <a:p>
+                      <a:r>
+                        <a:rPr sz="1700" b="0"/>
+                        <a:t>59,560</a:t>
+                      </a:r>
+                    </a:p>
+                  </a:txBody>
+                  <a:tcPr anchor="ctr"/>
+                </a:tc>
+                <a:tc>
+                  <a:txBody>
+                    <a:bodyPr/>
+                    <a:lstStyle/>
+                    <a:p>
+                      <a:r>
+                        <a:rPr sz="1700" b="0"/>
+                        <a:t>1.0×</a:t>
+                      </a:r>
+                    </a:p>
+                  </a:txBody>
+                  <a:tcPr anchor="ctr"/>
+                </a:tc>
+              </a:tr>
+              <a:tr h="487680">
+                <a:tc>
+                  <a:txBody>
+                    <a:bodyPr/>
+                    <a:lstStyle/>
+                    <a:p>
+                      <a:r>
+                        <a:rPr sz="1700" b="1"/>
+                        <a:t>+ aes32esmi / aes32esi hardware</a:t>
+                      </a:r>
+                    </a:p>
+                  </a:txBody>
+                  <a:tcPr anchor="ctr"/>
+                </a:tc>
+                <a:tc>
+                  <a:txBody>
+                    <a:bodyPr/>
+                    <a:lstStyle/>
+                    <a:p>
+                      <a:r>
+                        <a:rPr sz="1700" b="0"/>
+                        <a:t>6,260</a:t>
+                      </a:r>
+                    </a:p>
+                  </a:txBody>
+                  <a:tcPr anchor="ctr"/>
+                </a:tc>
+                <a:tc>
+                  <a:txBody>
+                    <a:bodyPr/>
+                    <a:lstStyle/>
+                    <a:p>
+                      <a:r>
+                        <a:rPr sz="1700" b="0">
+                          <a:solidFill>
+                            <a:srgbClr val="187A3B"/>
+                          </a:solidFill>
+                        </a:rPr>
+                        <a:t>9.5× faster</a:t>
+                      </a:r>
+                    </a:p>
+                  </a:txBody>
+                  <a:tcPr anchor="ctr"/>
+                </a:tc>
+              </a:tr>
+            </a:tbl>
+          </a:graphicData>
+        </a:graphic>
+      </p:graphicFrame>
+      <p:sp>
+        <p:nvSpPr>
+          <p:cNvPr id="19" name="TextBox 18"/>
+          <p:cNvSpPr txBox="1"/>
+          <p:nvPr/>
+        </p:nvSpPr>
+        <p:spPr>
+          <a:xfrm>
+            <a:off x="1280160" y="4389120"/>
+            <a:ext cx="9692640" cy="822960"/>
+          </a:xfrm>
+          <a:prstGeom prst="rect">
+            <a:avLst/>
+          </a:prstGeom>
+          <a:noFill/>
+        </p:spPr>
+        <p:txBody>
+          <a:bodyPr wrap="square">
+            <a:spAutoFit/>
+          </a:bodyPr>
+          <a:lstStyle/>
+          <a:p>
+            <a:r>
+              <a:rPr sz="1400" i="1">
+                <a:solidFill>
+                  <a:srgbClr val="555555"/>
+                </a:solidFill>
+              </a:rPr>
+              <a:t>The looped hardware version (6,260) is the starting point for the later optimisations: custom loop-unroll pass → 4,800, parallel DOM S-box → 4,104 (covered on the compiler and RTL slides).</a:t>
+            </a:r>
+          </a:p>
+        </p:txBody>
+      </p:sp>
     </p:spTree>
     <p:extLst>
       <p:ext uri="{BB962C8B-B14F-4D97-AF65-F5344CB8AC3E}">

</xml_diff>

<commit_message>
Slides: fill slide 2, native bottleneck chart (7), CPA + validation-pipeline figures (10,17), tighten 6/8, align baseline to 61,184; BASELINE.md canonical baseline -> 61,184
</commit_message>
<xml_diff>
--- a/PDP_group24.pptx
+++ b/PDP_group24.pptx
@@ -26321,8 +26321,8 @@
         </p:nvSpPr>
         <p:spPr>
           <a:xfrm>
-            <a:off x="717698" y="1045535"/>
-            <a:ext cx="10756603" cy="4206240"/>
+            <a:off x="717698" y="1097280"/>
+            <a:ext cx="10756603" cy="2011680"/>
           </a:xfrm>
           <a:prstGeom prst="rect">
             <a:avLst/>
@@ -26340,70 +26340,92 @@
           <a:p>
             <a:pPr>
               <a:spcAft>
-                <a:spcPts val="1000"/>
+                <a:spcPts val="600"/>
               </a:spcAft>
               <a:buFont typeface=""/>
               <a:buNone/>
             </a:pPr>
             <a:r>
-              <a:rPr sz="2000" b="0">
+              <a:rPr sz="1900" b="0" i="0">
                 <a:solidFill>
                   <a:srgbClr val="202020"/>
                 </a:solidFill>
               </a:rPr>
-              <a:t>The Zkne S-box and MixColumns switch a data-dependent number of bits each cycle, so the instantaneous power draw leaks the byte being processed.</a:t>
+              <a:t>The Zkne S-box and MixColumns switch a data-dependent number of bits, so power leaks the byte being processed.</a:t>
             </a:r>
           </a:p>
           <a:p>
             <a:pPr>
               <a:spcAft>
-                <a:spcPts val="1000"/>
+                <a:spcPts val="600"/>
               </a:spcAft>
-              <a:buNone/>
             </a:pPr>
             <a:r>
-              <a:rPr sz="2000" b="0">
+              <a:rPr sz="1900" b="0" i="0">
                 <a:solidFill>
                   <a:srgbClr val="202020"/>
                 </a:solidFill>
               </a:rPr>
-              <a:t>Correlation Power Analysis exploits this: correlating measured power against HW(SBOX[pt XOR guess]) makes the correct key guess separate from the other 255. On our unprotected core a key byte falls in about 100 traces.</a:t>
+              <a:t>Correlation Power Analysis turns that leakage into the key: about 100 traces on our unprotected core.</a:t>
             </a:r>
           </a:p>
           <a:p>
             <a:pPr>
               <a:spcAft>
-                <a:spcPts val="1000"/>
+                <a:spcPts val="600"/>
               </a:spcAft>
-              <a:buNone/>
             </a:pPr>
             <a:r>
-              <a:rPr sz="2000" b="0">
+              <a:rPr sz="1900" b="0" i="0">
                 <a:solidFill>
                   <a:srgbClr val="202020"/>
                 </a:solidFill>
               </a:rPr>
-              <a:t>Countermeasure: Domain-Oriented Masking (DOM). Every secret is split into two random shares that recombine only inside registered DOM-AND gates, so no single wire (and no glitch) correlates with the real value.</a:t>
+              <a:t>Countermeasure: Domain-Oriented Masking (DOM). Secrets are split into two random shares, recombined only inside registered gates, so no wire (or glitch) tracks the real value.</a:t>
             </a:r>
           </a:p>
           <a:p>
             <a:pPr>
               <a:spcAft>
-                <a:spcPts val="1000"/>
+                <a:spcPts val="600"/>
               </a:spcAft>
               <a:buNone/>
             </a:pPr>
             <a:r>
-              <a:rPr sz="1800" b="0">
+              <a:rPr sz="1500" b="0" i="0">
                 <a:solidFill>
                   <a:srgbClr val="555555"/>
                 </a:solidFill>
               </a:rPr>
-              <a:t>Design follows the TU Delft secure-Zkne paper of Kassimi, Aljuffri, Hamdioui and Taouil (2026).</a:t>
+              <a:t>Follows the TU Delft secure-Zkne paper of Kassimi, Aljuffri, Hamdioui and Taouil (2026).</a:t>
             </a:r>
           </a:p>
         </p:txBody>
       </p:sp>
+      <p:pic>
+        <p:nvPicPr>
+          <p:cNvPr id="17" name="Picture 16" descr="fig_cpa_concept.png"/>
+          <p:cNvPicPr>
+            <a:picLocks noChangeAspect="1"/>
+          </p:cNvPicPr>
+          <p:nvPr/>
+        </p:nvPicPr>
+        <p:blipFill>
+          <a:blip r:embed="rId2"/>
+          <a:stretch>
+            <a:fillRect/>
+          </a:stretch>
+        </p:blipFill>
+        <p:spPr>
+          <a:xfrm>
+            <a:off x="1463040" y="3977639"/>
+            <a:ext cx="9235440" cy="2435720"/>
+          </a:xfrm>
+          <a:prstGeom prst="rect">
+            <a:avLst/>
+          </a:prstGeom>
+        </p:spPr>
+      </p:pic>
     </p:spTree>
     <p:extLst>
       <p:ext uri="{BB962C8B-B14F-4D97-AF65-F5344CB8AC3E}">
@@ -29769,8 +29791,8 @@
         </p:nvSpPr>
         <p:spPr>
           <a:xfrm>
-            <a:off x="896112" y="1691640"/>
-            <a:ext cx="10424160" cy="4572000"/>
+            <a:off x="822960" y="1417320"/>
+            <a:ext cx="10607040" cy="457200"/>
           </a:xfrm>
           <a:prstGeom prst="rect">
             <a:avLst/>
@@ -29784,16 +29806,13 @@
           <a:lstStyle/>
           <a:p>
             <a:pPr>
-              <a:lnSpc>
-                <a:spcPct val="105000"/>
-              </a:lnSpc>
               <a:spcAft>
-                <a:spcPts val="1200"/>
+                <a:spcPts val="200"/>
               </a:spcAft>
               <a:buNone/>
             </a:pPr>
             <a:r>
-              <a:rPr sz="2000" b="1">
+              <a:rPr sz="2000" b="1" i="0">
                 <a:solidFill>
                   <a:srgbClr val="00B0F0"/>
                 </a:solidFill>
@@ -29801,118 +29820,113 @@
               <a:t>How we proved the masking works, in simulation and on hardware</a:t>
             </a:r>
           </a:p>
+        </p:txBody>
+      </p:sp>
+      <p:pic>
+        <p:nvPicPr>
+          <p:cNvPr id="4" name="Picture 3" descr="fig_validation_pipeline.png"/>
+          <p:cNvPicPr>
+            <a:picLocks noChangeAspect="1"/>
+          </p:cNvPicPr>
+          <p:nvPr/>
+        </p:nvPicPr>
+        <p:blipFill>
+          <a:blip r:embed="rId2"/>
+          <a:stretch>
+            <a:fillRect/>
+          </a:stretch>
+        </p:blipFill>
+        <p:spPr>
+          <a:xfrm>
+            <a:off x="1051560" y="1965960"/>
+            <a:ext cx="10058400" cy="2435192"/>
+          </a:xfrm>
+          <a:prstGeom prst="rect">
+            <a:avLst/>
+          </a:prstGeom>
+        </p:spPr>
+      </p:pic>
+      <p:sp>
+        <p:nvSpPr>
+          <p:cNvPr id="5" name="TextBox 4"/>
+          <p:cNvSpPr txBox="1"/>
+          <p:nvPr/>
+        </p:nvSpPr>
+        <p:spPr>
+          <a:xfrm>
+            <a:off x="868680" y="4297680"/>
+            <a:ext cx="10515600" cy="2194560"/>
+          </a:xfrm>
+          <a:prstGeom prst="rect">
+            <a:avLst/>
+          </a:prstGeom>
+          <a:noFill/>
+        </p:spPr>
+        <p:txBody>
+          <a:bodyPr wrap="square">
+            <a:spAutoFit/>
+          </a:bodyPr>
+          <a:lstStyle/>
           <a:p>
             <a:pPr>
-              <a:lnSpc>
-                <a:spcPct val="105000"/>
-              </a:lnSpc>
               <a:spcAft>
-                <a:spcPts val="1200"/>
+                <a:spcPts val="700"/>
               </a:spcAft>
               <a:buNone/>
             </a:pPr>
             <a:r>
-              <a:rPr sz="1900" b="0">
+              <a:rPr sz="1800" b="0" i="0">
                 <a:solidFill>
                   <a:srgbClr val="202020"/>
                 </a:solidFill>
               </a:rPr>
-              <a:t>Power proxy: a SystemVerilog testbench drives plaintexts through the hardware S-box in Vivado xsim and logs the Hamming weight of the captured result register per trace.</a:t>
+              <a:t>Power proxy = Hamming weight of the captured S-box result, logged per trace by a SystemVerilog testbench in Vivado xsim. The same rig drives the unprotected and the DOM S-box, so the before/after is clean.</a:t>
             </a:r>
           </a:p>
           <a:p>
             <a:pPr>
-              <a:lnSpc>
-                <a:spcPct val="105000"/>
-              </a:lnSpc>
               <a:spcAft>
-                <a:spcPts val="1200"/>
+                <a:spcPts val="700"/>
+              </a:spcAft>
+            </a:pPr>
+            <a:r>
+              <a:rPr sz="1800" b="0" i="0">
+                <a:solidFill>
+                  <a:srgbClr val="202020"/>
+                </a:solidFill>
+              </a:rPr>
+              <a:t>CPA: correlate power with HW(SBOX[pt XOR guess]) over all 256 guesses, 20 000 traces.</a:t>
+            </a:r>
+          </a:p>
+          <a:p>
+            <a:pPr>
+              <a:spcAft>
+                <a:spcPts val="700"/>
+              </a:spcAft>
+            </a:pPr>
+            <a:r>
+              <a:rPr sz="1800" b="0" i="0">
+                <a:solidFill>
+                  <a:srgbClr val="202020"/>
+                </a:solidFill>
+              </a:rPr>
+              <a:t>TVLA: Welch fixed-vs-random t-test, 40 000 traces; |t| &gt; 4.5 means first-order leakage.</a:t>
+            </a:r>
+          </a:p>
+          <a:p>
+            <a:pPr>
+              <a:spcAft>
+                <a:spcPts val="700"/>
               </a:spcAft>
               <a:buNone/>
             </a:pPr>
             <a:r>
-              <a:rPr sz="1900" b="0">
-                <a:solidFill>
-                  <a:srgbClr val="202020"/>
-                </a:solidFill>
-              </a:rPr>
-              <a:t>One harness, two S-boxes: the same rig runs against the unprotected and the DOM-masked S-box, producing identical CSVs. The only variable is the design, so the before/after is clean.</a:t>
-            </a:r>
-          </a:p>
-          <a:p>
-            <a:pPr>
-              <a:lnSpc>
-                <a:spcPct val="105000"/>
-              </a:lnSpc>
-              <a:spcAft>
-                <a:spcPts val="1200"/>
-              </a:spcAft>
-              <a:buNone/>
-            </a:pPr>
-            <a:r>
-              <a:rPr sz="1900" b="1">
-                <a:solidFill>
-                  <a:srgbClr val="202020"/>
-                </a:solidFill>
-              </a:rPr>
-              <a:t>Two standard attacks, scored in Python (numpy/scipy):</a:t>
-            </a:r>
-          </a:p>
-          <a:p>
-            <a:pPr lvl="1">
-              <a:lnSpc>
-                <a:spcPct val="105000"/>
-              </a:lnSpc>
-              <a:spcAft>
-                <a:spcPts val="1200"/>
-              </a:spcAft>
-              <a:buNone/>
-            </a:pPr>
-            <a:r>
-              <a:rPr sz="1800" b="0">
-                <a:solidFill>
-                  <a:srgbClr val="202020"/>
-                </a:solidFill>
-              </a:rPr>
-              <a:t>CPA: recover the key byte by correlating power with HW(SBOX[pt XOR guess]) over all 256 guesses, 20 000 traces.</a:t>
-            </a:r>
-          </a:p>
-          <a:p>
-            <a:pPr lvl="1">
-              <a:lnSpc>
-                <a:spcPct val="105000"/>
-              </a:lnSpc>
-              <a:spcAft>
-                <a:spcPts val="1200"/>
-              </a:spcAft>
-              <a:buNone/>
-            </a:pPr>
-            <a:r>
-              <a:rPr sz="1800" b="0">
-                <a:solidFill>
-                  <a:srgbClr val="202020"/>
-                </a:solidFill>
-              </a:rPr>
-              <a:t>TVLA: Welch fixed-vs-random t-test on 40 000 traces; |t| &gt; 4.5 means first-order leakage (ISO/IEC 17825).</a:t>
-            </a:r>
-          </a:p>
-          <a:p>
-            <a:pPr>
-              <a:lnSpc>
-                <a:spcPct val="105000"/>
-              </a:lnSpc>
-              <a:spcAft>
-                <a:spcPts val="1200"/>
-              </a:spcAft>
-              <a:buNone/>
-            </a:pPr>
-            <a:r>
-              <a:rPr sz="1800" b="0">
+              <a:rPr sz="1600" b="0" i="0">
                 <a:solidFill>
                   <a:srgbClr val="555555"/>
                 </a:solidFill>
               </a:rPr>
-              <a:t>Why simulation first: it isolates the register's switching with no analog noise, giving fast feedback in the RTL loop, alongside Rishi's CW305 hardware validation.</a:t>
+              <a:t>Simulation isolates the data-dependent switching with no analog noise, alongside Rishi's CW305 hardware validation.</a:t>
             </a:r>
           </a:p>
         </p:txBody>
@@ -30702,6 +30716,106 @@
               <a:t>Context: Why AES is needed?</a:t>
             </a:r>
             <a:endParaRPr lang="en-US"/>
+          </a:p>
+        </p:txBody>
+      </p:sp>
+      <p:sp>
+        <p:nvSpPr>
+          <p:cNvPr id="5" name="TextBox 4"/>
+          <p:cNvSpPr txBox="1"/>
+          <p:nvPr/>
+        </p:nvSpPr>
+        <p:spPr>
+          <a:xfrm>
+            <a:off x="822960" y="1554480"/>
+            <a:ext cx="10515600" cy="4206240"/>
+          </a:xfrm>
+          <a:prstGeom prst="rect">
+            <a:avLst/>
+          </a:prstGeom>
+          <a:noFill/>
+        </p:spPr>
+        <p:txBody>
+          <a:bodyPr wrap="square">
+            <a:spAutoFit/>
+          </a:bodyPr>
+          <a:lstStyle/>
+          <a:p>
+            <a:pPr>
+              <a:spcAft>
+                <a:spcPts val="1200"/>
+              </a:spcAft>
+              <a:buNone/>
+            </a:pPr>
+            <a:r>
+              <a:rPr sz="2200" b="1" i="0">
+                <a:solidFill>
+                  <a:srgbClr val="00B0F0"/>
+                </a:solidFill>
+              </a:rPr>
+              <a:t>AES-128 is the worldwide standard for symmetric encryption (NIST FIPS-197).</a:t>
+            </a:r>
+          </a:p>
+          <a:p>
+            <a:pPr>
+              <a:spcAft>
+                <a:spcPts val="1000"/>
+              </a:spcAft>
+            </a:pPr>
+            <a:r>
+              <a:rPr sz="2000" b="0" i="0">
+                <a:solidFill>
+                  <a:srgbClr val="202020"/>
+                </a:solidFill>
+              </a:rPr>
+              <a:t>It runs constantly on small embedded and IoT processors: TLS handshakes, secure boot, disk and message encryption.</a:t>
+            </a:r>
+          </a:p>
+          <a:p>
+            <a:pPr>
+              <a:spcAft>
+                <a:spcPts val="1000"/>
+              </a:spcAft>
+            </a:pPr>
+            <a:r>
+              <a:rPr sz="2000" b="0" i="0">
+                <a:solidFill>
+                  <a:srgbClr val="202020"/>
+                </a:solidFill>
+              </a:rPr>
+              <a:t>On a plain RISC-V core, AES is pure software: thousands of cycles per block, which is slow and power-hungry.</a:t>
+            </a:r>
+          </a:p>
+          <a:p>
+            <a:pPr>
+              <a:spcAft>
+                <a:spcPts val="1400"/>
+              </a:spcAft>
+            </a:pPr>
+            <a:r>
+              <a:rPr sz="2000" b="0" i="0">
+                <a:solidFill>
+                  <a:srgbClr val="202020"/>
+                </a:solidFill>
+              </a:rPr>
+              <a:t>Naive AES also leaks: an attacker measuring power can recover the key (side-channel attack).</a:t>
+            </a:r>
+          </a:p>
+          <a:p>
+            <a:pPr>
+              <a:spcAft>
+                <a:spcPts val="400"/>
+              </a:spcAft>
+              <a:buNone/>
+            </a:pPr>
+            <a:r>
+              <a:rPr sz="2000" b="1" i="0">
+                <a:solidFill>
+                  <a:srgbClr val="202020"/>
+                </a:solidFill>
+              </a:rPr>
+              <a:t>Our goal: make AES on RISC-V both fast (hardware instructions) and side-channel resistant.</a:t>
+            </a:r>
           </a:p>
         </p:txBody>
       </p:sp>
@@ -33982,8 +34096,8 @@
         </p:nvSpPr>
         <p:spPr>
           <a:xfrm>
-            <a:off x="716386" y="1049916"/>
-            <a:ext cx="10746783" cy="4352544"/>
+            <a:off x="716386" y="1097280"/>
+            <a:ext cx="10746783" cy="1463040"/>
           </a:xfrm>
         </p:spPr>
         <p:txBody>
@@ -33993,6 +34107,9 @@
           <a:lstStyle/>
           <a:p>
             <a:pPr>
+              <a:spcAft>
+                <a:spcPts val="600"/>
+              </a:spcAft>
               <a:buClr>
                 <a:srgbClr val="00A6D6"/>
               </a:buClr>
@@ -34000,21 +34117,31 @@
               <a:buChar char="•"/>
             </a:pPr>
             <a:r>
-              <a:rPr lang="en-US" b="1">
-                <a:cs typeface="Arial"/>
+              <a:rPr sz="2000" b="1" i="0">
+                <a:solidFill>
+                  <a:srgbClr val="202020"/>
+                </a:solidFill>
               </a:rPr>
-              <a:t>Pure C implementation </a:t>
-            </a:r>
-            <a:r>
-              <a:rPr lang="en-US">
-                <a:ea typeface="+mn-lt"/>
-                <a:cs typeface="+mn-lt"/>
-              </a:rPr>
-              <a:t>— using standard loads, stores, XORs, shifts</a:t>
+              <a:t>Pure C AES-128 on the unmodified RISCY core: standard loads, stores, XORs and shifts.</a:t>
             </a:r>
             <a:endParaRPr lang="en-US">
               <a:cs typeface="Arial"/>
             </a:endParaRPr>
+          </a:p>
+          <a:p>
+            <a:pPr>
+              <a:spcAft>
+                <a:spcPts val="600"/>
+              </a:spcAft>
+            </a:pPr>
+            <a:r>
+              <a:rPr sz="2000" b="0" i="0">
+                <a:solidFill>
+                  <a:srgbClr val="202020"/>
+                </a:solidFill>
+              </a:rPr>
+              <a:t>Table-based S-box and gf_mult MixColumns, all from data memory; no hardware acceleration.</a:t>
+            </a:r>
           </a:p>
         </p:txBody>
       </p:sp>
@@ -34039,8 +34166,8 @@
           </p:nvPr>
         </p:nvGraphicFramePr>
         <p:xfrm>
-          <a:off x="1215957" y="1856361"/>
-          <a:ext cx="9754684" cy="3147170"/>
+          <a:off x="1215957" y="2606040"/>
+          <a:ext cx="9754684" cy="1920240"/>
         </p:xfrm>
         <a:graphic>
           <a:graphicData uri="http://schemas.openxmlformats.org/drawingml/2006/table">
@@ -34064,7 +34191,7 @@
                   </a:extLst>
                 </a:gridCol>
               </a:tblGrid>
-              <a:tr h="629434">
+              <a:tr h="384048">
                 <a:tc>
                   <a:txBody>
                     <a:bodyPr/>
@@ -34099,7 +34226,7 @@
                   </a:ext>
                 </a:extLst>
               </a:tr>
-              <a:tr h="629434">
+              <a:tr h="384048">
                 <a:tc>
                   <a:txBody>
                     <a:bodyPr/>
@@ -34138,7 +34265,7 @@
                   </a:ext>
                 </a:extLst>
               </a:tr>
-              <a:tr h="629434">
+              <a:tr h="384048">
                 <a:tc>
                   <a:txBody>
                     <a:bodyPr/>
@@ -34177,7 +34304,7 @@
                   </a:ext>
                 </a:extLst>
               </a:tr>
-              <a:tr h="629434">
+              <a:tr h="384048">
                 <a:tc>
                   <a:txBody>
                     <a:bodyPr/>
@@ -34216,7 +34343,7 @@
                   </a:ext>
                 </a:extLst>
               </a:tr>
-              <a:tr h="629434">
+              <a:tr h="384048">
                 <a:tc>
                   <a:txBody>
                     <a:bodyPr/>
@@ -34259,6 +34386,45 @@
           </a:graphicData>
         </a:graphic>
       </p:graphicFrame>
+      <p:sp>
+        <p:nvSpPr>
+          <p:cNvPr id="17" name="TextBox 16"/>
+          <p:cNvSpPr txBox="1"/>
+          <p:nvPr/>
+        </p:nvSpPr>
+        <p:spPr>
+          <a:xfrm>
+            <a:off x="1216152" y="4800600"/>
+            <a:ext cx="9692640" cy="640080"/>
+          </a:xfrm>
+          <a:prstGeom prst="rect">
+            <a:avLst/>
+          </a:prstGeom>
+          <a:noFill/>
+        </p:spPr>
+        <p:txBody>
+          <a:bodyPr wrap="square">
+            <a:spAutoFit/>
+          </a:bodyPr>
+          <a:lstStyle/>
+          <a:p>
+            <a:pPr>
+              <a:spcAft>
+                <a:spcPts val="400"/>
+              </a:spcAft>
+              <a:buNone/>
+            </a:pPr>
+            <a:r>
+              <a:rPr sz="1600" b="1" i="0">
+                <a:solidFill>
+                  <a:srgbClr val="00B0F0"/>
+                </a:solidFill>
+              </a:rPr>
+              <a:t>61,184 cycles per block, almost all spent in MixColumns (next slide). This is the bottleneck the hardware targets.</a:t>
+            </a:r>
+          </a:p>
+        </p:txBody>
+      </p:sp>
     </p:spTree>
     <p:extLst>
       <p:ext uri="{BB962C8B-B14F-4D97-AF65-F5344CB8AC3E}">
@@ -34435,71 +34601,69 @@
           </a:p>
         </p:txBody>
       </p:sp>
-      <p:sp>
-        <p:nvSpPr>
-          <p:cNvPr id="8" name="Tijdelijke aanduiding voor tekst 7">
-            <a:extLst>
-              <a:ext uri="{FF2B5EF4-FFF2-40B4-BE49-F238E27FC236}">
-                <a16:creationId xmlns:a16="http://schemas.microsoft.com/office/drawing/2014/main" id="{DE224D77-92D0-28D6-8B11-36F1FB1C0A36}"/>
-              </a:ext>
-            </a:extLst>
-          </p:cNvPr>
-          <p:cNvSpPr>
-            <a:spLocks noGrp="1"/>
-          </p:cNvSpPr>
-          <p:nvPr>
-            <p:ph type="body" sz="quarter" idx="4294967295"/>
-          </p:nvPr>
-        </p:nvSpPr>
-        <p:spPr>
-          <a:xfrm>
-            <a:off x="716386" y="1049916"/>
-            <a:ext cx="10746783" cy="4782182"/>
-          </a:xfrm>
-        </p:spPr>
-        <p:txBody>
-          <a:bodyPr vert="horz" lIns="0" tIns="0" rIns="0" bIns="0" rtlCol="0" anchor="t">
-            <a:noAutofit/>
-          </a:bodyPr>
-          <a:lstStyle/>
-          <a:p>
-            <a:pPr lvl="2"/>
-            <a:endParaRPr lang="en-US">
-              <a:cs typeface="Arial"/>
-            </a:endParaRPr>
-          </a:p>
-        </p:txBody>
-      </p:sp>
       <p:pic>
         <p:nvPicPr>
-          <p:cNvPr id="2" name="Picture 1">
-            <a:extLst>
-              <a:ext uri="{FF2B5EF4-FFF2-40B4-BE49-F238E27FC236}">
-                <a16:creationId xmlns:a16="http://schemas.microsoft.com/office/drawing/2014/main" id="{ACB581EA-57A7-25C8-2189-9494BBA7E331}"/>
-              </a:ext>
-            </a:extLst>
-          </p:cNvPr>
+          <p:cNvPr id="17" name="Picture 16" descr="fig_bottlenecks.png"/>
           <p:cNvPicPr>
             <a:picLocks noChangeAspect="1"/>
           </p:cNvPicPr>
           <p:nvPr/>
         </p:nvPicPr>
         <p:blipFill>
-          <a:blip r:embed="rId2"/>
+          <a:blip r:embed="rId3"/>
           <a:stretch>
             <a:fillRect/>
           </a:stretch>
         </p:blipFill>
         <p:spPr>
           <a:xfrm>
-            <a:off x="2619375" y="2166938"/>
-            <a:ext cx="6953250" cy="2524125"/>
+            <a:off x="1554480" y="1554480"/>
+            <a:ext cx="8229600" cy="3512634"/>
           </a:xfrm>
           <a:prstGeom prst="rect">
             <a:avLst/>
           </a:prstGeom>
         </p:spPr>
       </p:pic>
+      <p:sp>
+        <p:nvSpPr>
+          <p:cNvPr id="18" name="TextBox 17"/>
+          <p:cNvSpPr txBox="1"/>
+          <p:nvPr/>
+        </p:nvSpPr>
+        <p:spPr>
+          <a:xfrm>
+            <a:off x="1554480" y="5074920"/>
+            <a:ext cx="8595360" cy="731520"/>
+          </a:xfrm>
+          <a:prstGeom prst="rect">
+            <a:avLst/>
+          </a:prstGeom>
+          <a:noFill/>
+        </p:spPr>
+        <p:txBody>
+          <a:bodyPr wrap="square">
+            <a:spAutoFit/>
+          </a:bodyPr>
+          <a:lstStyle/>
+          <a:p>
+            <a:pPr>
+              <a:spcAft>
+                <a:spcPts val="400"/>
+              </a:spcAft>
+              <a:buNone/>
+            </a:pPr>
+            <a:r>
+              <a:rPr sz="1700" b="1" i="0">
+                <a:solidFill>
+                  <a:srgbClr val="00B0F0"/>
+                </a:solidFill>
+              </a:rPr>
+              <a:t>MixColumns (the gf_mult inner loop) is 83.8% of all cycles, so it is the single thing worth accelerating in hardware.</a:t>
+            </a:r>
+          </a:p>
+        </p:txBody>
+      </p:sp>
     </p:spTree>
     <p:extLst>
       <p:ext uri="{BB962C8B-B14F-4D97-AF65-F5344CB8AC3E}">
@@ -34704,175 +34868,53 @@
           </a:bodyPr>
           <a:lstStyle/>
           <a:p>
-            <a:pPr lvl="2"/>
+            <a:pPr lvl="2">
+              <a:spcAft>
+                <a:spcPts val="1200"/>
+              </a:spcAft>
+            </a:pPr>
+            <a:r>
+              <a:rPr sz="2000" b="1" i="0">
+                <a:solidFill>
+                  <a:srgbClr val="202020"/>
+                </a:solidFill>
+              </a:rPr>
+              <a:t>The 186-instruction software mix_columns collapses to a few aes32esmi calls (no gf_mult).</a:t>
+            </a:r>
             <a:endParaRPr lang="en-US" b="1">
               <a:ea typeface="+mn-lt"/>
               <a:cs typeface="+mn-lt"/>
             </a:endParaRPr>
           </a:p>
           <a:p>
-            <a:pPr marL="285750" lvl="2" indent="-285750">
-              <a:buClr>
-                <a:srgbClr val="00A6D6"/>
-              </a:buClr>
-              <a:buSzPct val="120000"/>
-              <a:buFont typeface="Arial"/>
-              <a:buChar char="•"/>
+            <a:pPr>
+              <a:spcAft>
+                <a:spcPts val="1200"/>
+              </a:spcAft>
             </a:pPr>
             <a:r>
-              <a:rPr lang="en-US">
-                <a:ea typeface="+mn-lt"/>
-                <a:cs typeface="+mn-lt"/>
+              <a:rPr sz="2000" b="0" i="0">
+                <a:solidFill>
+                  <a:srgbClr val="202020"/>
+                </a:solidFill>
               </a:rPr>
-              <a:t>Eliminates all the </a:t>
+              <a:t>Runs entirely on registers: no BRAM loads for the S-box or MixColumns.</a:t>
             </a:r>
-            <a:r>
-              <a:rPr lang="en-US" err="1">
-                <a:latin typeface="Consolas"/>
-                <a:cs typeface="Arial"/>
-              </a:rPr>
-              <a:t>gf_mult</a:t>
-            </a:r>
-            <a:r>
-              <a:rPr lang="en-US">
-                <a:ea typeface="+mn-lt"/>
-                <a:cs typeface="+mn-lt"/>
-              </a:rPr>
-              <a:t> inlining (the 186-instruction </a:t>
-            </a:r>
-            <a:r>
-              <a:rPr lang="en-US" err="1">
-                <a:latin typeface="Consolas"/>
-                <a:cs typeface="Arial"/>
-              </a:rPr>
-              <a:t>mix_columns</a:t>
-            </a:r>
-            <a:r>
-              <a:rPr lang="en-US">
-                <a:ea typeface="+mn-lt"/>
-                <a:cs typeface="+mn-lt"/>
-              </a:rPr>
-              <a:t> becomes a handful of </a:t>
-            </a:r>
-            <a:r>
-              <a:rPr lang="en-US">
-                <a:latin typeface="Consolas"/>
-                <a:cs typeface="Arial"/>
-              </a:rPr>
-              <a:t>aes32esmi</a:t>
-            </a:r>
-            <a:r>
-              <a:rPr lang="en-US">
-                <a:ea typeface="+mn-lt"/>
-                <a:cs typeface="+mn-lt"/>
-              </a:rPr>
-              <a:t> calls)</a:t>
-            </a:r>
-            <a:endParaRPr lang="en-US"/>
           </a:p>
           <a:p>
-            <a:pPr marL="285750" lvl="2" indent="-285750">
-              <a:buClr>
-                <a:srgbClr val="00A6D6"/>
-              </a:buClr>
-              <a:buSzPct val="120000"/>
-              <a:buFont typeface="Arial"/>
-              <a:buChar char="•"/>
+            <a:pPr>
+              <a:spcAft>
+                <a:spcPts val="1200"/>
+              </a:spcAft>
             </a:pPr>
             <a:r>
-              <a:rPr lang="en-US">
-                <a:ea typeface="+mn-lt"/>
-                <a:cs typeface="+mn-lt"/>
+              <a:rPr sz="2000" b="0" i="0">
+                <a:solidFill>
+                  <a:srgbClr val="202020"/>
+                </a:solidFill>
               </a:rPr>
-              <a:t>Operates entirely on registers, with no BRAM loads for the S-box or </a:t>
+              <a:t>aes32esmi = SubBytes + ShiftRows + MixColumns + AddRoundKey, in one cycle.</a:t>
             </a:r>
-            <a:r>
-              <a:rPr lang="en-US" err="1">
-                <a:ea typeface="+mn-lt"/>
-                <a:cs typeface="+mn-lt"/>
-              </a:rPr>
-              <a:t>MixColumn</a:t>
-            </a:r>
-            <a:endParaRPr lang="en-US" err="1"/>
-          </a:p>
-          <a:p>
-            <a:pPr marL="285750" lvl="2" indent="-285750">
-              <a:buClr>
-                <a:srgbClr val="00A6D6"/>
-              </a:buClr>
-              <a:buSzPct val="120000"/>
-              <a:buFont typeface="Arial"/>
-              <a:buChar char="•"/>
-            </a:pPr>
-            <a:r>
-              <a:rPr lang="en-US">
-                <a:cs typeface="Arial"/>
-              </a:rPr>
-              <a:t>aes32esmi combines </a:t>
-            </a:r>
-            <a:r>
-              <a:rPr lang="en-US" err="1">
-                <a:cs typeface="Arial"/>
-              </a:rPr>
-              <a:t>SubBytes</a:t>
-            </a:r>
-            <a:r>
-              <a:rPr lang="en-US">
-                <a:cs typeface="Arial"/>
-              </a:rPr>
-              <a:t> + </a:t>
-            </a:r>
-            <a:r>
-              <a:rPr lang="en-US" err="1">
-                <a:cs typeface="Arial"/>
-              </a:rPr>
-              <a:t>ShiftRows</a:t>
-            </a:r>
-            <a:r>
-              <a:rPr lang="en-US">
-                <a:cs typeface="Arial"/>
-              </a:rPr>
-              <a:t> + </a:t>
-            </a:r>
-            <a:r>
-              <a:rPr lang="en-US" err="1">
-                <a:cs typeface="Arial"/>
-              </a:rPr>
-              <a:t>MixColumns</a:t>
-            </a:r>
-            <a:r>
-              <a:rPr lang="en-US">
-                <a:cs typeface="Arial"/>
-              </a:rPr>
-              <a:t> + AddRoundKey into </a:t>
-            </a:r>
-            <a:r>
-              <a:rPr lang="en-US" b="1">
-                <a:cs typeface="Arial"/>
-              </a:rPr>
-              <a:t>a single hardware instruction</a:t>
-            </a:r>
-            <a:r>
-              <a:rPr lang="en-US">
-                <a:cs typeface="Arial"/>
-              </a:rPr>
-              <a:t> that completes in </a:t>
-            </a:r>
-            <a:r>
-              <a:rPr lang="en-US" b="1">
-                <a:cs typeface="Arial"/>
-              </a:rPr>
-              <a:t>1 cycle</a:t>
-            </a:r>
-            <a:endParaRPr lang="en-US">
-              <a:cs typeface="Arial"/>
-            </a:endParaRPr>
-          </a:p>
-          <a:p>
-            <a:pPr lvl="2"/>
-            <a:endParaRPr lang="en-US" b="1">
-              <a:cs typeface="Arial"/>
-            </a:endParaRPr>
           </a:p>
         </p:txBody>
       </p:sp>
@@ -35237,8 +35279,8 @@
                     <a:lstStyle/>
                     <a:p>
                       <a:r>
-                        <a:rPr sz="1700" b="0"/>
-                        <a:t>59,560</a:t>
+                        <a:rPr sz="1700"/>
+                        <a:t>61,184</a:t>
                       </a:r>
                     </a:p>
                   </a:txBody>
@@ -35296,7 +35338,7 @@
                             <a:srgbClr val="187A3B"/>
                           </a:solidFill>
                         </a:rPr>
-                        <a:t>9.5× faster</a:t>
+                        <a:t>9.8x faster</a:t>
                       </a:r>
                     </a:p>
                   </a:txBody>

</xml_diff>